<commit_message>
Fix same-day timing wording in pre/post lesson resources
Pre-visit resources now speak about the excursion as upcoming and
post-visit resources as recently past — removed "today"/"tomorrow"
phrasing from brain breaks, exit tickets, checklists and the slide
player planning instructions; regenerated all 32 PPTX decks.

Co-Authored-By: Claude Fable 5 <noreply@anthropic.com>
</commit_message>
<xml_diff>
--- a/public/resources/pptx/post-pdhpe-s3.pptx
+++ b/public/resources/pptx/post-pdhpe-s3.pptx
@@ -7179,7 +7179,7 @@
                 </a:solidFill>
                 <a:latin typeface="Calibri"/>
               </a:rPr>
-              <a:t>You have 60 seconds to draw an animal from today's visit. Show your class and see if they can guess it!</a:t>
+              <a:t>You have 60 seconds to draw a Taronga Zoo animal. Show your class and see if they can guess it!</a:t>
             </a:r>
           </a:p>
         </p:txBody>
@@ -7941,7 +7941,7 @@
                 </a:solidFill>
                 <a:latin typeface="Calibri"/>
               </a:rPr>
-              <a:t>Describe one animal movement you observed today using at least two biomechanical terms.</a:t>
+              <a:t>Describe one animal movement you observed at Taronga Zoo using at least two biomechanical terms.</a:t>
             </a:r>
           </a:p>
         </p:txBody>

</xml_diff>